<commit_message>
Final changes in Legal & Compliance PDF
</commit_message>
<xml_diff>
--- a/proposal/Pitch-Deck-Aug-14.pptx
+++ b/proposal/Pitch-Deck-Aug-14.pptx
@@ -663,17 +663,11 @@
               <a:rPr lang="en-US" sz="1200" b="0" i="0" kern="1200" dirty="0">
                 <a:effectLst/>
               </a:rPr>
-              <a:t>The other twenty-six items, full sourcing and mitigation, are in the supplementary PDF. </a:t>
-            </a:r>
-            <a:r>
-              <a:rPr lang="en-US" sz="1200" b="0" i="0" kern="1200">
-                <a:effectLst/>
-              </a:rPr>
-              <a:t>This slide is the headline, the register is the evidence.</a:t>
-            </a:r>
-          </a:p>
-          <a:p>
-            <a:endParaRPr lang="en-US"/>
+              <a:t>The other twenty-six items, full sourcing and mitigation, are in the supplementary PDF. This slide is the headline, the register is the evidence.</a:t>
+            </a:r>
+          </a:p>
+          <a:p>
+            <a:endParaRPr lang="en-US" dirty="0"/>
           </a:p>
         </p:txBody>
       </p:sp>
@@ -7234,14 +7228,47 @@
           <a:p>
             <a:pPr algn="l"/>
             <a:r>
-              <a:rPr sz="1000" b="0">
+              <a:rPr sz="1000" b="0" dirty="0">
                 <a:solidFill>
                   <a:srgbClr val="6B7280"/>
                 </a:solidFill>
                 <a:latin typeface="Aptos"/>
               </a:rPr>
-              <a:t>Full company-by-company sourcing: Competitor Analysis PDF (docs/Competitor-analysis.md)</a:t>
-            </a:r>
+              <a:t>Full company-by-company sourcing: Competitor</a:t>
+            </a:r>
+            <a:r>
+              <a:rPr lang="en-US" sz="1000" b="0" dirty="0">
+                <a:solidFill>
+                  <a:srgbClr val="6B7280"/>
+                </a:solidFill>
+                <a:latin typeface="Aptos"/>
+              </a:rPr>
+              <a:t>_</a:t>
+            </a:r>
+            <a:r>
+              <a:rPr sz="1000" b="0" dirty="0">
+                <a:solidFill>
+                  <a:srgbClr val="6B7280"/>
+                </a:solidFill>
+                <a:latin typeface="Aptos"/>
+              </a:rPr>
+              <a:t>Analysis</a:t>
+            </a:r>
+            <a:r>
+              <a:rPr lang="en-US" sz="1000" dirty="0">
+                <a:solidFill>
+                  <a:srgbClr val="6B7280"/>
+                </a:solidFill>
+                <a:latin typeface="Aptos"/>
+              </a:rPr>
+              <a:t>.pdf</a:t>
+            </a:r>
+            <a:endParaRPr sz="1000" b="0" dirty="0">
+              <a:solidFill>
+                <a:srgbClr val="6B7280"/>
+              </a:solidFill>
+              <a:latin typeface="Aptos"/>
+            </a:endParaRPr>
           </a:p>
         </p:txBody>
       </p:sp>
@@ -7329,7 +7356,7 @@
         </p:nvSpPr>
         <p:spPr>
           <a:xfrm>
-            <a:off x="0" y="0"/>
+            <a:off x="-182880" y="0"/>
             <a:ext cx="12191695" cy="6858000"/>
           </a:xfrm>
           <a:prstGeom prst="rect">
@@ -8553,16 +8580,39 @@
           <a:bodyPr wrap="square" lIns="0" tIns="0" rIns="0" bIns="0" rtlCol="0" anchor="t"/>
           <a:lstStyle/>
           <a:p>
-            <a:pPr algn="l"/>
-            <a:r>
-              <a:rPr sz="1000" b="0">
+            <a:r>
+              <a:rPr sz="1000" b="0" dirty="0">
                 <a:solidFill>
                   <a:srgbClr val="6B7280"/>
                 </a:solidFill>
                 <a:latin typeface="Aptos"/>
               </a:rPr>
-              <a:t>Full risk register: Legal &amp; Compliance Risk Assessment PDF (docs/legal-risk.md)</a:t>
-            </a:r>
+              <a:t>Full risk register: </a:t>
+            </a:r>
+            <a:r>
+              <a:rPr lang="en-US" sz="1000" dirty="0">
+                <a:solidFill>
+                  <a:srgbClr val="6B7280"/>
+                </a:solidFill>
+                <a:latin typeface="Aptos"/>
+              </a:rPr>
+              <a:t>BlockMed_Legal_and_Compliance.</a:t>
+            </a:r>
+            <a:r>
+              <a:rPr lang="en-US" sz="1000" b="0" dirty="0">
+                <a:solidFill>
+                  <a:srgbClr val="6B7280"/>
+                </a:solidFill>
+                <a:latin typeface="Aptos"/>
+              </a:rPr>
+              <a:t>pdf</a:t>
+            </a:r>
+            <a:endParaRPr sz="1000" b="0" dirty="0">
+              <a:solidFill>
+                <a:srgbClr val="6B7280"/>
+              </a:solidFill>
+              <a:latin typeface="Aptos"/>
+            </a:endParaRPr>
           </a:p>
         </p:txBody>
       </p:sp>

</xml_diff>